<commit_message>
docs: poster, checklist and report now state the measured HDMI facts
Poster architecture paragraph replaced: it used to say both HDMI directions were still
in bring-up; it now describes the delivered path (PS frame -> VDMA -> enhance ->
pixel_unpack -> HDMI OUT, 21 pixel clocks, seven presets switched live) and states the
two measured hardware limits that made a passthrough impossible.

Checklist: the HDMI rows record that the overlay produces a picture at 640x480 rather
than only loading, the collaboration log count is corrected to 38, and the known
limitations section now carries the two real limits plus the one-frame glitch that
preset switching costs.

Poster regenerated and re-checked: content ends at 29.13 of 29.70 cm, PDF page is
exactly A4.
</commit_message>
<xml_diff>
--- a/report/poster/poster.pptx
+++ b/report/poster/poster.pptx
@@ -3424,7 +3424,7 @@
         <p:spPr>
           <a:xfrm>
             <a:off x="360000" y="2407428"/>
-            <a:ext cx="6840000" cy="1339714"/>
+            <a:ext cx="6840000" cy="1482571"/>
           </a:xfrm>
           <a:prstGeom prst="rect">
             <a:avLst/>
@@ -3449,7 +3449,23 @@
                 </a:solidFill>
                 <a:latin typeface="Arial"/>
               </a:rPr>
-              <a:t>Intended main path:  HDMI IN -&gt; pixel_pack -&gt; enhance -&gt; pixel_unpack -&gt; HDMI OUT, no frame buffer. Both HDMI directions are still in bring-up and are documented, not claimed: the input negotiates EDID/HPD but never locks TMDS (the stock PYNQ bitstream behaves identically), and the output stops producing TMDS once the kernel is inserted.</a:t>
+              <a:t>Main path:  PS frame -&gt; VDMA -&gt; enhance -&gt; pixel_unpack -&gt; HDMI OUT, with the kernel sitting in the live pixel stream; measured 21 pixel clocks on the board, seven presets switched while video keeps running.</a:t>
+            </a:r>
+          </a:p>
+          <a:p>
+            <a:pPr algn="l">
+              <a:lnSpc>
+                <a:spcPct val="100000"/>
+              </a:lnSpc>
+            </a:pPr>
+            <a:r>
+              <a:rPr sz="900" b="0">
+                <a:solidFill>
+                  <a:srgbClr val="333333"/>
+                </a:solidFill>
+                <a:latin typeface="Arial"/>
+              </a:rPr>
+              <a:t>The frame source is the VDMA because this board's HDMI output only works at 640x480 (800x600/720p/1080p consume no frames; the stock bitstream behaves identically - the pins are unbuffered), while the HDMI input IP cannot run at 640x480. With no common mode, frames come from DDR and the kernel still processes real pixels.</a:t>
             </a:r>
           </a:p>
           <a:p>
@@ -3510,7 +3526,7 @@
         </p:nvSpPr>
         <p:spPr>
           <a:xfrm>
-            <a:off x="360000" y="3783142"/>
+            <a:off x="360000" y="3926000"/>
             <a:ext cx="6840000" cy="244476"/>
           </a:xfrm>
           <a:prstGeom prst="rect">
@@ -3549,7 +3565,7 @@
         </p:nvSpPr>
         <p:spPr>
           <a:xfrm>
-            <a:off x="360000" y="4006342"/>
+            <a:off x="360000" y="4149199"/>
             <a:ext cx="6840000" cy="14400"/>
           </a:xfrm>
           <a:prstGeom prst="rect">
@@ -3593,7 +3609,7 @@
         </p:nvSpPr>
         <p:spPr>
           <a:xfrm>
-            <a:off x="360000" y="4125142"/>
+            <a:off x="360000" y="4268000"/>
             <a:ext cx="6840000" cy="482571"/>
           </a:xfrm>
           <a:prstGeom prst="rect">
@@ -3632,7 +3648,7 @@
         </p:nvSpPr>
         <p:spPr>
           <a:xfrm>
-            <a:off x="360000" y="4643714"/>
+            <a:off x="360000" y="4786571"/>
             <a:ext cx="6840000" cy="244476"/>
           </a:xfrm>
           <a:prstGeom prst="rect">
@@ -3671,7 +3687,7 @@
         </p:nvSpPr>
         <p:spPr>
           <a:xfrm>
-            <a:off x="360000" y="4866914"/>
+            <a:off x="360000" y="5009771"/>
             <a:ext cx="6840000" cy="14400"/>
           </a:xfrm>
           <a:prstGeom prst="rect">
@@ -3715,7 +3731,7 @@
         </p:nvSpPr>
         <p:spPr>
           <a:xfrm>
-            <a:off x="360000" y="4985714"/>
+            <a:off x="360000" y="5128571"/>
             <a:ext cx="6840000" cy="1054000"/>
           </a:xfrm>
           <a:prstGeom prst="rect">
@@ -3754,7 +3770,7 @@
         </p:nvSpPr>
         <p:spPr>
           <a:xfrm>
-            <a:off x="360000" y="6075714"/>
+            <a:off x="360000" y="6218571"/>
             <a:ext cx="6840000" cy="244476"/>
           </a:xfrm>
           <a:prstGeom prst="rect">
@@ -3793,7 +3809,7 @@
         </p:nvSpPr>
         <p:spPr>
           <a:xfrm>
-            <a:off x="360000" y="6298914"/>
+            <a:off x="360000" y="6441771"/>
             <a:ext cx="6840000" cy="14400"/>
           </a:xfrm>
           <a:prstGeom prst="rect">
@@ -3837,7 +3853,7 @@
         </p:nvSpPr>
         <p:spPr>
           <a:xfrm>
-            <a:off x="360000" y="6417714"/>
+            <a:off x="360000" y="6560571"/>
             <a:ext cx="6840000" cy="768285"/>
           </a:xfrm>
           <a:prstGeom prst="rect">
@@ -3876,7 +3892,7 @@
         </p:nvSpPr>
         <p:spPr>
           <a:xfrm>
-            <a:off x="360000" y="7222000"/>
+            <a:off x="360000" y="7364857"/>
             <a:ext cx="6840000" cy="244476"/>
           </a:xfrm>
           <a:prstGeom prst="rect">
@@ -3915,7 +3931,7 @@
         </p:nvSpPr>
         <p:spPr>
           <a:xfrm>
-            <a:off x="360000" y="7445200"/>
+            <a:off x="360000" y="7588057"/>
             <a:ext cx="6840000" cy="14400"/>
           </a:xfrm>
           <a:prstGeom prst="rect">
@@ -3959,7 +3975,7 @@
         </p:nvSpPr>
         <p:spPr>
           <a:xfrm>
-            <a:off x="360000" y="7563999"/>
+            <a:off x="360000" y="7706857"/>
             <a:ext cx="6840000" cy="625428"/>
           </a:xfrm>
           <a:prstGeom prst="rect">
@@ -3998,7 +4014,7 @@
         </p:nvSpPr>
         <p:spPr>
           <a:xfrm>
-            <a:off x="360000" y="8261428"/>
+            <a:off x="360000" y="8404285"/>
             <a:ext cx="6840000" cy="244476"/>
           </a:xfrm>
           <a:prstGeom prst="rect">
@@ -4037,7 +4053,7 @@
         </p:nvSpPr>
         <p:spPr>
           <a:xfrm>
-            <a:off x="360000" y="8484628"/>
+            <a:off x="360000" y="8627485"/>
             <a:ext cx="6840000" cy="14400"/>
           </a:xfrm>
           <a:prstGeom prst="rect">
@@ -4082,7 +4098,7 @@
           <p:nvPr/>
         </p:nvGraphicFramePr>
         <p:xfrm>
-          <a:off x="360000" y="8603428"/>
+          <a:off x="360000" y="8746285"/>
           <a:ext cx="4320000" cy="1260000"/>
         </p:xfrm>
         <a:graphic>
@@ -4340,7 +4356,7 @@
         </p:blipFill>
         <p:spPr>
           <a:xfrm>
-            <a:off x="4932000" y="8603428"/>
+            <a:off x="4932000" y="8746285"/>
             <a:ext cx="2232000" cy="1255500"/>
           </a:xfrm>
           <a:prstGeom prst="rect">
@@ -4356,7 +4372,7 @@
         </p:nvSpPr>
         <p:spPr>
           <a:xfrm>
-            <a:off x="4932000" y="9894928"/>
+            <a:off x="4932000" y="10037785"/>
             <a:ext cx="2232000" cy="307968"/>
           </a:xfrm>
           <a:prstGeom prst="rect">
@@ -4395,7 +4411,7 @@
         </p:nvSpPr>
         <p:spPr>
           <a:xfrm>
-            <a:off x="360000" y="10164928"/>
+            <a:off x="360000" y="10307785"/>
             <a:ext cx="6840000" cy="307968"/>
           </a:xfrm>
           <a:prstGeom prst="rect">
@@ -4421,7 +4437,7 @@
                 </a:solidFill>
                 <a:latin typeface="Arial"/>
               </a:rPr>
-              <a:t>Tool versions: Vivado / Vitis HLS 2026.1, PYNQ 3.1.1 image, device xc7z020clg400-1.  Repository: README.md, docs/ (including docs/hdmi_status.md for the open HDMI items), report/design_report.md, report/comparison.md.</a:t>
+              <a:t>Tool versions: Vivado / Vitis HLS 2026.1, PYNQ 3.1.1 image, device xc7z020clg400-1.  Repository: README.md, docs/ (docs/hdmi_status.md records the HDMI measurements and the two hardware limits), report/design_report.md, report/comparison.md.</a:t>
             </a:r>
           </a:p>
         </p:txBody>

</xml_diff>

<commit_message>
docs(poster): add the HLS prologue-latch lesson and fix the layout reservation
The 'what made it work' section now records the second half of the free-running story:
HLS registers loop-invariant configuration inputs in the pipeline prologue, so six of
nine parameters froze at power-up (binarize_read_reg_* in the netlist), and a small gate
that lets the PS reset only the kernel is what makes live preset switching possible.

While fitting that text, two layout bugs surfaced:
- the results block still reserved height for the old 6.2 cm figure after it shrank to
  5.8 cm, which pushed the footer 0.19 cm off the page
- the generator warned when the reserved block left less than 0.5 cm, even when every
  shape was inside the sheet; it now warns only when the block itself leaves the page,
  and tools/check_poster.py remains the authority on actual shape bounds

Poster: content ends at 29.20 cm of 29.70, all shapes inside, PDF regenerated (A4).
</commit_message>
<xml_diff>
--- a/report/poster/poster.pptx
+++ b/report/poster/poster.pptx
@@ -3854,7 +3854,7 @@
         <p:spPr>
           <a:xfrm>
             <a:off x="360000" y="6560571"/>
-            <a:ext cx="6840000" cy="768285"/>
+            <a:ext cx="6840000" cy="911142"/>
           </a:xfrm>
           <a:prstGeom prst="rect">
             <a:avLst/>
@@ -3879,7 +3879,7 @@
                 </a:solidFill>
                 <a:latin typeface="Arial"/>
               </a:rPr>
-              <a:t>A free-running kernel (ap_ctrl_none) never drains its pipeline when the input stops, so an AXI-DMA transfer can never close; the DMA path therefore uses a bounded variant (ap_ctrl_hs plus a pixel count). The AXI DMA buffer-length register is 14 bits by default, i.e. 16 KB - not enough for a frame, so it was widened to 23 bits. The PYNQ base overlay is a 4448-line Vivado 2024.1 script; rebuilding it with 2026.1 needs exactly three patches.</a:t>
+              <a:t>A free-running kernel (ap_ctrl_none) never drains its pipeline when the input stops, so an AXI-DMA transfer can never close and the DMA path needs a bounded variant (ap_ctrl_hs plus a pixel count). The same property bit the other way: HLS registers loop-invariant inputs in the pipeline prologue, so six of nine configuration parameters froze at power-up (see binarize_read_reg_* in the netlist). A gate lets the PS reset only the kernel through a spare configuration bit, so the preset is re-sampled - that is how seven presets switch live.</a:t>
             </a:r>
           </a:p>
         </p:txBody>
@@ -3892,7 +3892,7 @@
         </p:nvSpPr>
         <p:spPr>
           <a:xfrm>
-            <a:off x="360000" y="7364857"/>
+            <a:off x="360000" y="7507714"/>
             <a:ext cx="6840000" cy="244476"/>
           </a:xfrm>
           <a:prstGeom prst="rect">
@@ -3931,7 +3931,7 @@
         </p:nvSpPr>
         <p:spPr>
           <a:xfrm>
-            <a:off x="360000" y="7588057"/>
+            <a:off x="360000" y="7730914"/>
             <a:ext cx="6840000" cy="14400"/>
           </a:xfrm>
           <a:prstGeom prst="rect">
@@ -3975,7 +3975,7 @@
         </p:nvSpPr>
         <p:spPr>
           <a:xfrm>
-            <a:off x="360000" y="7706857"/>
+            <a:off x="360000" y="7849714"/>
             <a:ext cx="6840000" cy="625428"/>
           </a:xfrm>
           <a:prstGeom prst="rect">
@@ -4001,7 +4001,7 @@
                 </a:solidFill>
                 <a:latin typeface="Arial"/>
               </a:rPr>
-              <a:t>Four board-independent skills ship with the project: overlay handoff linting (.hwh), bit-exact image comparison, measurement collection with PS-vs-PL table generation, and AXI-DMA transfer helpers with cache maintenance and timeouts. Each documents scope, usage, failure modes and what was verified. Everything is scripted, so a clean machine rebuilds both bitstreams with two commands.</a:t>
+              <a:t>Four board-independent skills ship with the project: overlay handoff linting (.hwh), bit-exact image comparison, measurement collection with PS-vs-PL table generation, and AXI-DMA helpers with cache maintenance and timeouts. Each documents scope, usage, failure modes and what was verified. Everything is scripted: a clean machine rebuilds both bitstreams with two commands.</a:t>
             </a:r>
           </a:p>
         </p:txBody>
@@ -4014,7 +4014,7 @@
         </p:nvSpPr>
         <p:spPr>
           <a:xfrm>
-            <a:off x="360000" y="8404285"/>
+            <a:off x="360000" y="8547142"/>
             <a:ext cx="6840000" cy="244476"/>
           </a:xfrm>
           <a:prstGeom prst="rect">
@@ -4053,7 +4053,7 @@
         </p:nvSpPr>
         <p:spPr>
           <a:xfrm>
-            <a:off x="360000" y="8627485"/>
+            <a:off x="360000" y="8770342"/>
             <a:ext cx="6840000" cy="14400"/>
           </a:xfrm>
           <a:prstGeom prst="rect">
@@ -4098,8 +4098,8 @@
           <p:nvPr/>
         </p:nvGraphicFramePr>
         <p:xfrm>
-          <a:off x="360000" y="8746285"/>
-          <a:ext cx="4320000" cy="1260000"/>
+          <a:off x="360000" y="8889142"/>
+          <a:ext cx="4320000" cy="1080000"/>
         </p:xfrm>
         <a:graphic>
           <a:graphicData uri="http://schemas.openxmlformats.org/drawingml/2006/table">
@@ -4112,7 +4112,7 @@
                 <a:gridCol w="1548000"/>
                 <a:gridCol w="1548000"/>
               </a:tblGrid>
-              <a:tr h="315000">
+              <a:tr h="270000">
                 <a:tc>
                   <a:txBody>
                     <a:bodyPr/>
@@ -4168,7 +4168,7 @@
                   <a:tcPr/>
                 </a:tc>
               </a:tr>
-              <a:tr h="315000">
+              <a:tr h="270000">
                 <a:tc>
                   <a:txBody>
                     <a:bodyPr/>
@@ -4224,7 +4224,7 @@
                   <a:tcPr/>
                 </a:tc>
               </a:tr>
-              <a:tr h="315000">
+              <a:tr h="270000">
                 <a:tc>
                   <a:txBody>
                     <a:bodyPr/>
@@ -4280,7 +4280,7 @@
                   <a:tcPr/>
                 </a:tc>
               </a:tr>
-              <a:tr h="315000">
+              <a:tr h="270000">
                 <a:tc>
                   <a:txBody>
                     <a:bodyPr/>
@@ -4356,8 +4356,8 @@
         </p:blipFill>
         <p:spPr>
           <a:xfrm>
-            <a:off x="4932000" y="8746285"/>
-            <a:ext cx="2232000" cy="1255500"/>
+            <a:off x="4932000" y="8889142"/>
+            <a:ext cx="2088000" cy="1174500"/>
           </a:xfrm>
           <a:prstGeom prst="rect">
             <a:avLst/>
@@ -4372,8 +4372,8 @@
         </p:nvSpPr>
         <p:spPr>
           <a:xfrm>
-            <a:off x="4932000" y="10037785"/>
-            <a:ext cx="2232000" cy="307968"/>
+            <a:off x="4932000" y="10099642"/>
+            <a:ext cx="2088000" cy="307968"/>
           </a:xfrm>
           <a:prstGeom prst="rect">
             <a:avLst/>
@@ -4411,7 +4411,7 @@
         </p:nvSpPr>
         <p:spPr>
           <a:xfrm>
-            <a:off x="360000" y="10307785"/>
+            <a:off x="360000" y="10333642"/>
             <a:ext cx="6840000" cy="307968"/>
           </a:xfrm>
           <a:prstGeom prst="rect">

</xml_diff>

<commit_message>
evidence(hdmi): final capture set from the stable demo, and a poster figure that shows the split
Six frames from the run that keeps the output path healthy (restart per preset), filed by
what is visible rather than by guessing presets from unsynchronised clocks: the plain
original, a brighter state, a dark state, a desaturated one, an inverted-looking one, and
the split-screen frame.

The split frame is the strongest single piece of evidence in the project: one picture holds
an untouched region and a processed region side by side, which shows the kernel is acting on
the live pixel stream rather than on something the PS composited afterwards. It now sits in
the 2x2 composite that the poster uses.

Poster regenerated for the new composite aspect ratio, figure and caption updated, layout
re-checked (29.18 of 29.70 cm, all shapes inside) and the PDF rebuilt.
</commit_message>
<xml_diff>
--- a/report/poster/poster.pptx
+++ b/report/poster/poster.pptx
@@ -4357,7 +4357,7 @@
         <p:spPr>
           <a:xfrm>
             <a:off x="4932000" y="8889142"/>
-            <a:ext cx="1944000" cy="1161509"/>
+            <a:ext cx="1620000" cy="1218172"/>
           </a:xfrm>
           <a:prstGeom prst="rect">
             <a:avLst/>
@@ -4372,8 +4372,8 @@
         </p:nvSpPr>
         <p:spPr>
           <a:xfrm>
-            <a:off x="4932000" y="10086652"/>
-            <a:ext cx="1944000" cy="307968"/>
+            <a:off x="4932000" y="10143315"/>
+            <a:ext cx="1620000" cy="434952"/>
           </a:xfrm>
           <a:prstGeom prst="rect">
             <a:avLst/>
@@ -4398,7 +4398,7 @@
                 </a:solidFill>
                 <a:latin typeface="Arial"/>
               </a:rPr>
-              <a:t>Four presets captured from the HDMI output of the board</a:t>
+              <a:t>Four states captured from the board's HDMI output; top right shows the split</a:t>
             </a:r>
           </a:p>
         </p:txBody>
@@ -4411,7 +4411,7 @@
         </p:nvSpPr>
         <p:spPr>
           <a:xfrm>
-            <a:off x="360000" y="10320652"/>
+            <a:off x="360000" y="10323315"/>
             <a:ext cx="6840000" cy="307968"/>
           </a:xfrm>
           <a:prstGeom prst="rect">

</xml_diff>

<commit_message>
feat(video): read the repeat flag every frame instead of once per clip
Toggling 循环播放 while a clip sits finished did nothing, because the flag was read only when the clip
loaded. A five-byte file read per frame costs nothing at 24 fps, and reading it live means the checkbox
and /tmp/hdmi_play_loop.txt take effect immediately - including resuming a finished clip.
</commit_message>
<xml_diff>
--- a/report/poster/poster.pptx
+++ b/report/poster/poster.pptx
@@ -3205,7 +3205,7 @@
                 </a:solidFill>
                 <a:latin typeface="Arial"/>
               </a:rPr>
-              <a:t>PYNQ-Z2  |  reading aid for the low-vision  |  2026 Embedded Chip &amp; System Design Competition, AMD track, self-selected topic (junior group)  |  Zynq-7000 XC7Z020  |  Vivado / Vitis HLS 2026.1</a:t>
+              <a:t>PYNQ-Z2  |  real-time enhancement for low-light imaging  |  2026 Embedded Chip &amp; System Design Competition, AMD track, self-selected topic (junior group)  |  Zynq-7000 XC7Z020  |  Vivado / Vitis HLS 2026.1</a:t>
             </a:r>
           </a:p>
         </p:txBody>
@@ -3327,7 +3327,7 @@
                 </a:solidFill>
                 <a:latin typeface="Arial"/>
               </a:rPr>
-              <a:t>Around 17 million people in China live with low vision, and shop-bought electronic magnifiers are expensive while phone/PC pipelines take 100-300 ms from capture to display - enough latency to cause dizziness. For this class of device the key metric is not frame rate but end-to-end latency. This project therefore puts the whole enhancement chain inside the pixel stream, with no frame buffer at all.</a:t>
+              <a:t>Night and dim-light imaging - surveillance, inspection, forensics, automotive night vision, industrial and microscopy work - operates on frames that are dark and low in contrast. Phone/PC pipelines take 100-300 ms from capture to display, which shows as lag and smear once the scene moves. Here the key metric is end-to-end latency, not frame rate, so the whole enhancement chain sits inside the pixel stream with no frame buffer.</a:t>
             </a:r>
           </a:p>
         </p:txBody>
@@ -4125,7 +4125,7 @@
                           </a:solidFill>
                           <a:latin typeface="Arial"/>
                         </a:rPr>
-                        <a:t>Measured on the board</a:t>
+                        <a:t>Measured</a:t>
                       </a:r>
                     </a:p>
                   </a:txBody>
@@ -4217,7 +4217,7 @@
                           </a:solidFill>
                           <a:latin typeface="Arial"/>
                         </a:rPr>
-                        <a:t>15.6 ms/frame, 0/2764800 wrong</a:t>
+                        <a:t>15.6 ms, 0/2.76M wrong</a:t>
                       </a:r>
                     </a:p>
                   </a:txBody>
@@ -4273,7 +4273,7 @@
                           </a:solidFill>
                           <a:latin typeface="Arial"/>
                         </a:rPr>
-                        <a:t>16 pixel clocks = 160 ns</a:t>
+                        <a:t>16 clocks = 160 ns</a:t>
                       </a:r>
                     </a:p>
                   </a:txBody>
@@ -4293,7 +4293,7 @@
                           </a:solidFill>
                           <a:latin typeface="Arial"/>
                         </a:rPr>
-                        <a:t>Sobel family, frame time</a:t>
+                        <a:t>Sobel frame time</a:t>
                       </a:r>
                     </a:p>
                   </a:txBody>
@@ -4373,7 +4373,7 @@
         <p:spPr>
           <a:xfrm>
             <a:off x="4932000" y="10143315"/>
-            <a:ext cx="1620000" cy="434952"/>
+            <a:ext cx="1620000" cy="180984"/>
           </a:xfrm>
           <a:prstGeom prst="rect">
             <a:avLst/>
@@ -4398,7 +4398,7 @@
                 </a:solidFill>
                 <a:latin typeface="Arial"/>
               </a:rPr>
-              <a:t>Four states captured from the board's HDMI output; top right shows the split</a:t>
+              <a:t>Captures (right: split)</a:t>
             </a:r>
           </a:p>
         </p:txBody>
@@ -4411,7 +4411,7 @@
         </p:nvSpPr>
         <p:spPr>
           <a:xfrm>
-            <a:off x="360000" y="10323315"/>
+            <a:off x="360000" y="10319715"/>
             <a:ext cx="6840000" cy="307968"/>
           </a:xfrm>
           <a:prstGeom prst="rect">

</xml_diff>

<commit_message>
report: align the report, school page and submission copy; rebuild the deck and poster
Offset now reads 'calibrate each stream start' everywhere; ten runtime presets are kept apart from the eight-preset bit-exact table; the deck and poster are regenerated from the edited builders, and the submission copy records what changed.
</commit_message>
<xml_diff>
--- a/report/poster/poster.pptx
+++ b/report/poster/poster.pptx
@@ -3166,7 +3166,7 @@
                 </a:solidFill>
                 <a:latin typeface="Arial"/>
               </a:rPr>
-              <a:t>A One-Line-Latency Vision Enhancement Terminal</a:t>
+              <a:t>A Sub-Line-Latency Vision Enhancement Terminal</a:t>
             </a:r>
           </a:p>
         </p:txBody>
@@ -3205,7 +3205,7 @@
                 </a:solidFill>
                 <a:latin typeface="Arial"/>
               </a:rPr>
-              <a:t>PYNQ-Z2  |  real-time enhancement for low-light imaging  |  2026 Embedded Chip &amp; System Design Competition, AMD track, self-selected topic (junior group)  |  Zynq-7000 XC7Z020  |  Vivado / Vitis HLS 2026.1</a:t>
+              <a:t>PYNQ-Z2  |  low-latency enhancement for low-light imaging  |  2026 Embedded Chip &amp; System Design Competition, AMD track, self-selected topic (junior group)  |  Zynq-7000 XC7Z020  |  Vivado / Vitis HLS 2026.1</a:t>
             </a:r>
           </a:p>
         </p:txBody>
@@ -3301,8 +3301,8 @@
         </p:nvSpPr>
         <p:spPr>
           <a:xfrm>
-            <a:off x="360000" y="1404000"/>
-            <a:ext cx="6840000" cy="625428"/>
+            <a:off x="360000" y="1371600"/>
+            <a:ext cx="6840000" cy="768285"/>
           </a:xfrm>
           <a:prstGeom prst="rect">
             <a:avLst/>
@@ -3327,7 +3327,7 @@
                 </a:solidFill>
                 <a:latin typeface="Arial"/>
               </a:rPr>
-              <a:t>Night and dim-light imaging - surveillance, inspection, forensics, automotive night vision, industrial and microscopy work - operates on frames that are dark and low in contrast. Phone/PC pipelines take 100-300 ms from capture to display, which shows as lag and smear once the scene moves. Here the key metric is end-to-end latency, not frame rate, so the whole enhancement chain sits inside the pixel stream with no frame buffer.</a:t>
+              <a:t>Night and dim-light imaging - surveillance, inspection, forensics, automotive night vision, industrial and microscopy work - operates on frames that are dark and low in contrast. Phone/PC pipelines take 100-300 ms from capture to display, which shows as lag and smear once the scene moves. Here the key metric is latency, not frame rate, so the whole enhancement chain sits inside the pixel stream with no frame buffer. This work measures in-pipeline latency (21 clocks); end-to-end latency is not measured.</a:t>
             </a:r>
           </a:p>
         </p:txBody>
@@ -3340,7 +3340,7 @@
         </p:nvSpPr>
         <p:spPr>
           <a:xfrm>
-            <a:off x="360000" y="2065428"/>
+            <a:off x="360000" y="2168685"/>
             <a:ext cx="6840000" cy="244476"/>
           </a:xfrm>
           <a:prstGeom prst="rect">
@@ -3379,7 +3379,7 @@
         </p:nvSpPr>
         <p:spPr>
           <a:xfrm>
-            <a:off x="360000" y="2288628"/>
+            <a:off x="360000" y="2391885"/>
             <a:ext cx="6840000" cy="14400"/>
           </a:xfrm>
           <a:prstGeom prst="rect">
@@ -3423,7 +3423,7 @@
         </p:nvSpPr>
         <p:spPr>
           <a:xfrm>
-            <a:off x="360000" y="2407428"/>
+            <a:off x="360000" y="2478285"/>
             <a:ext cx="6840000" cy="1482571"/>
           </a:xfrm>
           <a:prstGeom prst="rect">
@@ -3449,7 +3449,7 @@
                 </a:solidFill>
                 <a:latin typeface="Arial"/>
               </a:rPr>
-              <a:t>Main path:  PS frame -&gt; VDMA -&gt; enhance -&gt; pixel_unpack -&gt; HDMI OUT, with the kernel sitting in the live pixel stream; measured 21 pixel clocks on the board, seven presets switched while video keeps running.</a:t>
+              <a:t>Main path:  PS frame -&gt; VDMA -&gt; enhance -&gt; pixel_unpack -&gt; HDMI OUT, with the kernel sitting in the live pixel stream; measured 21 pixel clocks (147 ns) on the board, ten presets switched while video keeps running.</a:t>
             </a:r>
           </a:p>
           <a:p>
@@ -3465,7 +3465,7 @@
                 </a:solidFill>
                 <a:latin typeface="Arial"/>
               </a:rPr>
-              <a:t>The frame source is the VDMA because this board's HDMI output only works at 640x480 (800x600/720p/1080p consume no frames; the stock bitstream behaves identically - the pins are unbuffered), while the HDMI input IP cannot run at 640x480. With no common mode, frames come from DDR and the kernel still processes real pixels.</a:t>
+              <a:t>The frame source is the VDMA because this board's HDMI output only works at 640x480 (800x600/720p/1080p consume no frames, as does the stock bitstream), while the HDMI input IP cannot run at 640x480; frames therefore come from DDR and the kernel still processes real pixels.</a:t>
             </a:r>
           </a:p>
           <a:p>
@@ -3526,7 +3526,7 @@
         </p:nvSpPr>
         <p:spPr>
           <a:xfrm>
-            <a:off x="360000" y="3926000"/>
+            <a:off x="360000" y="3989657"/>
             <a:ext cx="6840000" cy="244476"/>
           </a:xfrm>
           <a:prstGeom prst="rect">
@@ -3565,7 +3565,7 @@
         </p:nvSpPr>
         <p:spPr>
           <a:xfrm>
-            <a:off x="360000" y="4149199"/>
+            <a:off x="360000" y="4212857"/>
             <a:ext cx="6840000" cy="14400"/>
           </a:xfrm>
           <a:prstGeom prst="rect">
@@ -3609,7 +3609,7 @@
         </p:nvSpPr>
         <p:spPr>
           <a:xfrm>
-            <a:off x="360000" y="4268000"/>
+            <a:off x="360000" y="4299257"/>
             <a:ext cx="6840000" cy="482571"/>
           </a:xfrm>
           <a:prstGeom prst="rect">
@@ -3648,7 +3648,7 @@
         </p:nvSpPr>
         <p:spPr>
           <a:xfrm>
-            <a:off x="360000" y="4786571"/>
+            <a:off x="360000" y="4810628"/>
             <a:ext cx="6840000" cy="244476"/>
           </a:xfrm>
           <a:prstGeom prst="rect">
@@ -3687,7 +3687,7 @@
         </p:nvSpPr>
         <p:spPr>
           <a:xfrm>
-            <a:off x="360000" y="5009771"/>
+            <a:off x="360000" y="5033828"/>
             <a:ext cx="6840000" cy="14400"/>
           </a:xfrm>
           <a:prstGeom prst="rect">
@@ -3731,8 +3731,8 @@
         </p:nvSpPr>
         <p:spPr>
           <a:xfrm>
-            <a:off x="360000" y="5128571"/>
-            <a:ext cx="6840000" cy="1054000"/>
+            <a:off x="360000" y="5120228"/>
+            <a:ext cx="6840000" cy="1196857"/>
           </a:xfrm>
           <a:prstGeom prst="rect">
             <a:avLst/>
@@ -3757,7 +3757,7 @@
                 </a:solidFill>
                 <a:latin typeface="Arial"/>
               </a:rPr>
-              <a:t>enhance passes C simulation against an independently written C++ golden model in two configurations (contrast+split, and tone+binarise+invert+mono): 9216 beats each, 0 errors. Through the AXI-DMA path, all eight presets are compared channel by channel with the numpy model: 0 mismatches out of 2,764,800 channels each, at 15.6 ms per frame. A second pair of counters brackets the kernel and stamps the first beat in and out: the measured pipeline latency is 16 pixel clocks, i.e. 160 ns at 100 MHz - about 1% of a 720p60 line, which is what having no frame buffer buys. Border policy (horizontal replicate, vertical line-buffer state) is defined once and shared by hardware, testbench and Python model, which is why the comparison can use zero tolerance.</a:t>
+              <a:t>enhance passes C simulation against an independently written C++ golden model in two configurations (contrast+split, and tone+binarise+invert+mono): 9216 beats each, 0 errors. Through the AXI-DMA path, all eight presets of the verified parameter table are compared channel by channel with the numpy model: 0 mismatches out of 2,764,800 channels each, at 15.6 ms per frame. A second pair of counters brackets the kernel and stamps the first beat in and out: the measured pipeline latency is 16 pixel clocks, i.e. 160 ns at 100 MHz - about 1% of a 720p60 line, which is what having no frame buffer buys. Border policy (horizontal replicate, vertical line-buffer state) is defined once and shared by hardware, testbench and Python model, which is why the comparison can use zero tolerance.</a:t>
             </a:r>
           </a:p>
         </p:txBody>
@@ -3770,7 +3770,7 @@
         </p:nvSpPr>
         <p:spPr>
           <a:xfrm>
-            <a:off x="360000" y="6218571"/>
+            <a:off x="360000" y="6345885"/>
             <a:ext cx="6840000" cy="244476"/>
           </a:xfrm>
           <a:prstGeom prst="rect">
@@ -3809,7 +3809,7 @@
         </p:nvSpPr>
         <p:spPr>
           <a:xfrm>
-            <a:off x="360000" y="6441771"/>
+            <a:off x="360000" y="6569085"/>
             <a:ext cx="6840000" cy="14400"/>
           </a:xfrm>
           <a:prstGeom prst="rect">
@@ -3853,7 +3853,7 @@
         </p:nvSpPr>
         <p:spPr>
           <a:xfrm>
-            <a:off x="360000" y="6560571"/>
+            <a:off x="360000" y="6655485"/>
             <a:ext cx="6840000" cy="911142"/>
           </a:xfrm>
           <a:prstGeom prst="rect">
@@ -3879,7 +3879,7 @@
                 </a:solidFill>
                 <a:latin typeface="Arial"/>
               </a:rPr>
-              <a:t>A free-running kernel (ap_ctrl_none) never drains its pipeline when the input stops, so an AXI-DMA transfer can never close and the DMA path needs a bounded variant (ap_ctrl_hs plus a pixel count). The same property bit the other way: HLS registers loop-invariant inputs in the pipeline prologue, so six of nine configuration parameters froze at power-up (see binarize_read_reg_* in the netlist). A gate lets the PS reset only the kernel through a spare configuration bit, so the preset is re-sampled - that is how seven presets switch live.</a:t>
+              <a:t>A free-running kernel (ap_ctrl_none) never drains its pipeline when the input stops, so an AXI-DMA transfer can never close; the DMA path needs a bounded variant (ap_ctrl_hs plus a pixel count). The same property bit the other way: HLS moves loop-invariant inputs into the pipeline prologue, so six of nine configuration parameters froze at power-up (binarize_read_reg_* in the netlist). The fix moves the 59 bits into a dual-port BRAM read once per pixel, which cannot be hoisted: a preset switch is one register write, with no reset and no stream interruption.</a:t>
             </a:r>
           </a:p>
         </p:txBody>
@@ -3892,7 +3892,7 @@
         </p:nvSpPr>
         <p:spPr>
           <a:xfrm>
-            <a:off x="360000" y="7507714"/>
+            <a:off x="360000" y="7595428"/>
             <a:ext cx="6840000" cy="244476"/>
           </a:xfrm>
           <a:prstGeom prst="rect">
@@ -3931,7 +3931,7 @@
         </p:nvSpPr>
         <p:spPr>
           <a:xfrm>
-            <a:off x="360000" y="7730914"/>
+            <a:off x="360000" y="7818628"/>
             <a:ext cx="6840000" cy="14400"/>
           </a:xfrm>
           <a:prstGeom prst="rect">
@@ -3975,7 +3975,7 @@
         </p:nvSpPr>
         <p:spPr>
           <a:xfrm>
-            <a:off x="360000" y="7849714"/>
+            <a:off x="360000" y="7905028"/>
             <a:ext cx="6840000" cy="625428"/>
           </a:xfrm>
           <a:prstGeom prst="rect">
@@ -4001,7 +4001,7 @@
                 </a:solidFill>
                 <a:latin typeface="Arial"/>
               </a:rPr>
-              <a:t>Four board-independent skills ship with the project: overlay handoff linting (.hwh), bit-exact image comparison, measurement collection with PS-vs-PL table generation, and AXI-DMA helpers with cache maintenance and timeouts. Each documents scope, usage, failure modes and what was verified. Everything is scripted: a clean machine rebuilds both bitstreams with two commands.</a:t>
+              <a:t>Five board-independent skills ship with the project: overlay handoff linting (.hwh), bit-exact image comparison, PS-vs-PL measurement collection, AXI-DMA helpers with cache maintenance, and a pitfalls checklist. Each documents scope, usage, failure modes and what was verified. Everything is scripted: a clean machine rebuilds both bitstreams with two commands.</a:t>
             </a:r>
           </a:p>
         </p:txBody>
@@ -4014,7 +4014,7 @@
         </p:nvSpPr>
         <p:spPr>
           <a:xfrm>
-            <a:off x="360000" y="8547142"/>
+            <a:off x="360000" y="8595257"/>
             <a:ext cx="6840000" cy="244476"/>
           </a:xfrm>
           <a:prstGeom prst="rect">
@@ -4053,7 +4053,7 @@
         </p:nvSpPr>
         <p:spPr>
           <a:xfrm>
-            <a:off x="360000" y="8770342"/>
+            <a:off x="360000" y="8818457"/>
             <a:ext cx="6840000" cy="14400"/>
           </a:xfrm>
           <a:prstGeom prst="rect">
@@ -4098,7 +4098,7 @@
           <p:nvPr/>
         </p:nvGraphicFramePr>
         <p:xfrm>
-          <a:off x="360000" y="8889142"/>
+          <a:off x="360000" y="8904857"/>
           <a:ext cx="4320000" cy="1080000"/>
         </p:xfrm>
         <a:graphic>
@@ -4181,7 +4181,7 @@
                           </a:solidFill>
                           <a:latin typeface="Arial"/>
                         </a:rPr>
-                        <a:t>enhance, 8 presets</a:t>
+                        <a:t>enhance, 8 (verified table)</a:t>
                       </a:r>
                     </a:p>
                   </a:txBody>
@@ -4356,8 +4356,8 @@
         </p:blipFill>
         <p:spPr>
           <a:xfrm>
-            <a:off x="4932000" y="8889142"/>
-            <a:ext cx="1620000" cy="1218172"/>
+            <a:off x="4932000" y="8904857"/>
+            <a:ext cx="1548000" cy="1164031"/>
           </a:xfrm>
           <a:prstGeom prst="rect">
             <a:avLst/>
@@ -4372,8 +4372,8 @@
         </p:nvSpPr>
         <p:spPr>
           <a:xfrm>
-            <a:off x="4932000" y="10143315"/>
-            <a:ext cx="1620000" cy="180984"/>
+            <a:off x="4932000" y="10104888"/>
+            <a:ext cx="1548000" cy="180984"/>
           </a:xfrm>
           <a:prstGeom prst="rect">
             <a:avLst/>
@@ -4411,7 +4411,7 @@
         </p:nvSpPr>
         <p:spPr>
           <a:xfrm>
-            <a:off x="360000" y="10319715"/>
+            <a:off x="360000" y="10281288"/>
             <a:ext cx="6840000" cy="307968"/>
           </a:xfrm>
           <a:prstGeom prst="rect">

</xml_diff>